<commit_message>
Update Matelligence contact domain
</commit_message>
<xml_diff>
--- a/Matelligence_Pitch_Deck.pptx
+++ b/Matelligence_Pitch_Deck.pptx
@@ -1754,7 +1754,7 @@
                 <a:ea typeface="Inter" pitchFamily="34" charset="-122"/>
                 <a:cs typeface="Inter" pitchFamily="34" charset="-120"/>
               </a:rPr>
-              <a:t>hello@matelligence.xyz</a:t>
+              <a:t>hello@matelligence.online</a:t>
             </a:r>
             <a:endParaRPr lang="en-US" sz="1300" dirty="0"/>
           </a:p>
@@ -6237,7 +6237,7 @@
                 <a:ea typeface="Inter" pitchFamily="34" charset="-122"/>
                 <a:cs typeface="Inter" pitchFamily="34" charset="-120"/>
               </a:rPr>
-              <a:t>hello@matelligence.xyz</a:t>
+              <a:t>hello@matelligence.online</a:t>
             </a:r>
             <a:endParaRPr lang="en-US" sz="1300" dirty="0"/>
           </a:p>

</xml_diff>